<commit_message>
Refresh chapter figure pipeline assets
</commit_message>
<xml_diff>
--- a/article/ppt/Chapter01_local.pptx
+++ b/article/ppt/Chapter01_local.pptx
@@ -457,6 +457,216 @@
     </a:lvl9pPr>
   </p:notesStyle>
 </p:notesMaster>
+</file>
+
+<file path=ppt/notesSlides/notesSlide1.xml><?xml version="1.0" encoding="utf-8"?>
+<p:notes xmlns:a="http://schemas.openxmlformats.org/drawingml/2006/main" xmlns:p="http://schemas.openxmlformats.org/presentationml/2006/main" xmlns:r="http://schemas.openxmlformats.org/officeDocument/2006/relationships">
+  <p:cSld>
+    <p:spTree>
+      <p:nvGrpSpPr>
+        <p:cNvPr id="1" name=""/>
+        <p:cNvGrpSpPr/>
+        <p:nvPr/>
+      </p:nvGrpSpPr>
+      <p:grpSpPr>
+        <a:xfrm>
+          <a:off x="0" y="0"/>
+          <a:ext cx="0" cy="0"/>
+          <a:chOff x="0" y="0"/>
+          <a:chExt cx="0" cy="0"/>
+        </a:xfrm>
+      </p:grpSpPr>
+      <p:sp>
+        <p:nvSpPr>
+          <p:cNvPr id="2" name="Slide Image Placeholder 1"/>
+          <p:cNvSpPr>
+            <a:spLocks noGrp="1"/>
+          </p:cNvSpPr>
+          <p:nvPr>
+            <p:ph type="sldImg" idx="2"/>
+          </p:nvPr>
+        </p:nvSpPr>
+        <p:spPr/>
+      </p:sp>
+      <p:sp>
+        <p:nvSpPr>
+          <p:cNvPr id="3" name="Notes Placeholder 2"/>
+          <p:cNvSpPr>
+            <a:spLocks noGrp="1"/>
+          </p:cNvSpPr>
+          <p:nvPr>
+            <p:ph type="body" idx="3" sz="quarter"/>
+          </p:nvPr>
+        </p:nvSpPr>
+        <p:spPr/>
+        <p:txBody>
+          <a:bodyPr/>
+          <a:lstStyle/>
+          <a:p>
+            <a:r>
+              <a:t>FIG:01</a:t>
+            </a:r>
+          </a:p>
+        </p:txBody>
+      </p:sp>
+      <p:sp>
+        <p:nvSpPr>
+          <p:cNvPr id="4" name="Slide Number Placeholder 3"/>
+          <p:cNvSpPr>
+            <a:spLocks noGrp="1"/>
+          </p:cNvSpPr>
+          <p:nvPr>
+            <p:ph type="sldNum" idx="5" sz="quarter"/>
+          </p:nvPr>
+        </p:nvSpPr>
+        <p:spPr/>
+      </p:sp>
+    </p:spTree>
+  </p:cSld>
+  <p:clrMapOvr>
+    <a:masterClrMapping/>
+  </p:clrMapOvr>
+</p:notes>
+</file>
+
+<file path=ppt/notesSlides/notesSlide2.xml><?xml version="1.0" encoding="utf-8"?>
+<p:notes xmlns:a="http://schemas.openxmlformats.org/drawingml/2006/main" xmlns:p="http://schemas.openxmlformats.org/presentationml/2006/main" xmlns:r="http://schemas.openxmlformats.org/officeDocument/2006/relationships">
+  <p:cSld>
+    <p:spTree>
+      <p:nvGrpSpPr>
+        <p:cNvPr id="1" name=""/>
+        <p:cNvGrpSpPr/>
+        <p:nvPr/>
+      </p:nvGrpSpPr>
+      <p:grpSpPr>
+        <a:xfrm>
+          <a:off x="0" y="0"/>
+          <a:ext cx="0" cy="0"/>
+          <a:chOff x="0" y="0"/>
+          <a:chExt cx="0" cy="0"/>
+        </a:xfrm>
+      </p:grpSpPr>
+      <p:sp>
+        <p:nvSpPr>
+          <p:cNvPr id="2" name="Slide Image Placeholder 1"/>
+          <p:cNvSpPr>
+            <a:spLocks noGrp="1"/>
+          </p:cNvSpPr>
+          <p:nvPr>
+            <p:ph type="sldImg" idx="2"/>
+          </p:nvPr>
+        </p:nvSpPr>
+        <p:spPr/>
+      </p:sp>
+      <p:sp>
+        <p:nvSpPr>
+          <p:cNvPr id="3" name="Notes Placeholder 2"/>
+          <p:cNvSpPr>
+            <a:spLocks noGrp="1"/>
+          </p:cNvSpPr>
+          <p:nvPr>
+            <p:ph type="body" idx="3" sz="quarter"/>
+          </p:nvPr>
+        </p:nvSpPr>
+        <p:spPr/>
+        <p:txBody>
+          <a:bodyPr/>
+          <a:lstStyle/>
+          <a:p>
+            <a:r>
+              <a:t>FIG:02</a:t>
+            </a:r>
+          </a:p>
+        </p:txBody>
+      </p:sp>
+      <p:sp>
+        <p:nvSpPr>
+          <p:cNvPr id="4" name="Slide Number Placeholder 3"/>
+          <p:cNvSpPr>
+            <a:spLocks noGrp="1"/>
+          </p:cNvSpPr>
+          <p:nvPr>
+            <p:ph type="sldNum" idx="5" sz="quarter"/>
+          </p:nvPr>
+        </p:nvSpPr>
+        <p:spPr/>
+      </p:sp>
+    </p:spTree>
+  </p:cSld>
+  <p:clrMapOvr>
+    <a:masterClrMapping/>
+  </p:clrMapOvr>
+</p:notes>
+</file>
+
+<file path=ppt/notesSlides/notesSlide3.xml><?xml version="1.0" encoding="utf-8"?>
+<p:notes xmlns:a="http://schemas.openxmlformats.org/drawingml/2006/main" xmlns:p="http://schemas.openxmlformats.org/presentationml/2006/main" xmlns:r="http://schemas.openxmlformats.org/officeDocument/2006/relationships">
+  <p:cSld>
+    <p:spTree>
+      <p:nvGrpSpPr>
+        <p:cNvPr id="1" name=""/>
+        <p:cNvGrpSpPr/>
+        <p:nvPr/>
+      </p:nvGrpSpPr>
+      <p:grpSpPr>
+        <a:xfrm>
+          <a:off x="0" y="0"/>
+          <a:ext cx="0" cy="0"/>
+          <a:chOff x="0" y="0"/>
+          <a:chExt cx="0" cy="0"/>
+        </a:xfrm>
+      </p:grpSpPr>
+      <p:sp>
+        <p:nvSpPr>
+          <p:cNvPr id="2" name="Slide Image Placeholder 1"/>
+          <p:cNvSpPr>
+            <a:spLocks noGrp="1"/>
+          </p:cNvSpPr>
+          <p:nvPr>
+            <p:ph type="sldImg" idx="2"/>
+          </p:nvPr>
+        </p:nvSpPr>
+        <p:spPr/>
+      </p:sp>
+      <p:sp>
+        <p:nvSpPr>
+          <p:cNvPr id="3" name="Notes Placeholder 2"/>
+          <p:cNvSpPr>
+            <a:spLocks noGrp="1"/>
+          </p:cNvSpPr>
+          <p:nvPr>
+            <p:ph type="body" idx="3" sz="quarter"/>
+          </p:nvPr>
+        </p:nvSpPr>
+        <p:spPr/>
+        <p:txBody>
+          <a:bodyPr/>
+          <a:lstStyle/>
+          <a:p>
+            <a:r>
+              <a:t>FIG:03</a:t>
+            </a:r>
+          </a:p>
+        </p:txBody>
+      </p:sp>
+      <p:sp>
+        <p:nvSpPr>
+          <p:cNvPr id="4" name="Slide Number Placeholder 3"/>
+          <p:cNvSpPr>
+            <a:spLocks noGrp="1"/>
+          </p:cNvSpPr>
+          <p:nvPr>
+            <p:ph type="sldNum" idx="5" sz="quarter"/>
+          </p:nvPr>
+        </p:nvSpPr>
+        <p:spPr/>
+      </p:sp>
+    </p:spTree>
+  </p:cSld>
+  <p:clrMapOvr>
+    <a:masterClrMapping/>
+  </p:clrMapOvr>
+</p:notes>
 </file>
 
 <file path=ppt/slideLayouts/slideLayout1.xml><?xml version="1.0" encoding="utf-8"?>

</xml_diff>